<commit_message>
migration pptx added for thesis defence
</commit_message>
<xml_diff>
--- a/migration/pptx file/main.pptx
+++ b/migration/pptx file/main.pptx
@@ -32,6 +32,8 @@
     <p:sldId id="264" r:id="rId26"/>
     <p:sldId id="269" r:id="rId27"/>
     <p:sldId id="265" r:id="rId28"/>
+    <p:sldId id="273" r:id="rId29"/>
+    <p:sldId id="274" r:id="rId30"/>
   </p:sldIdLst>
   <p:sldSz cx="12192000" cy="6858000"/>
   <p:notesSz cx="7559675" cy="10691813"/>
@@ -741,6 +743,13 @@
                 </c:ext>
               </c:extLst>
             </c:dLbl>
+            <c:spPr>
+              <a:noFill/>
+              <a:ln>
+                <a:noFill/>
+              </a:ln>
+              <a:effectLst/>
+            </c:spPr>
             <c:dLblPos val="outEnd"/>
             <c:showLegendKey val="0"/>
             <c:showVal val="1"/>
@@ -18425,6 +18434,265 @@
           <a:lstStyle/>
           <a:p>
             <a:pPr algn="ctr"/>
+            <a:endParaRPr lang="en-US" sz="1600" b="0" strike="noStrike" spc="-1" dirty="0">
+              <a:solidFill>
+                <a:srgbClr val="000000"/>
+              </a:solidFill>
+              <a:latin typeface="Arial" panose="020B0604020202020204" pitchFamily="34" charset="0"/>
+              <a:cs typeface="Arial" panose="020B0604020202020204" pitchFamily="34" charset="0"/>
+            </a:endParaRPr>
+          </a:p>
+        </p:txBody>
+      </p:sp>
+      <p:pic>
+        <p:nvPicPr>
+          <p:cNvPr id="3" name="Picture 2">
+            <a:extLst>
+              <a:ext uri="{FF2B5EF4-FFF2-40B4-BE49-F238E27FC236}">
+                <a16:creationId xmlns:a16="http://schemas.microsoft.com/office/drawing/2014/main" id="{A417C890-0F7D-3BC4-C092-D68B22C4A9D6}"/>
+              </a:ext>
+            </a:extLst>
+          </p:cNvPr>
+          <p:cNvPicPr>
+            <a:picLocks noChangeAspect="1"/>
+          </p:cNvPicPr>
+          <p:nvPr/>
+        </p:nvPicPr>
+        <p:blipFill>
+          <a:blip r:embed="rId2" cstate="print">
+            <a:extLst>
+              <a:ext uri="{28A0092B-C50C-407E-A947-70E740481C1C}">
+                <a14:useLocalDpi xmlns:a14="http://schemas.microsoft.com/office/drawing/2010/main" val="0"/>
+              </a:ext>
+            </a:extLst>
+          </a:blip>
+          <a:stretch>
+            <a:fillRect/>
+          </a:stretch>
+        </p:blipFill>
+        <p:spPr>
+          <a:xfrm>
+            <a:off x="6708580" y="0"/>
+            <a:ext cx="3859306" cy="6858000"/>
+          </a:xfrm>
+          <a:prstGeom prst="rect">
+            <a:avLst/>
+          </a:prstGeom>
+        </p:spPr>
+      </p:pic>
+      <p:pic>
+        <p:nvPicPr>
+          <p:cNvPr id="8" name="Picture 7">
+            <a:extLst>
+              <a:ext uri="{FF2B5EF4-FFF2-40B4-BE49-F238E27FC236}">
+                <a16:creationId xmlns:a16="http://schemas.microsoft.com/office/drawing/2014/main" id="{C6023756-23D3-C1CB-3BED-7327D32712A1}"/>
+              </a:ext>
+            </a:extLst>
+          </p:cNvPr>
+          <p:cNvPicPr>
+            <a:picLocks noChangeAspect="1"/>
+          </p:cNvPicPr>
+          <p:nvPr/>
+        </p:nvPicPr>
+        <p:blipFill>
+          <a:blip r:embed="rId3" cstate="print">
+            <a:extLst>
+              <a:ext uri="{28A0092B-C50C-407E-A947-70E740481C1C}">
+                <a14:useLocalDpi xmlns:a14="http://schemas.microsoft.com/office/drawing/2010/main" val="0"/>
+              </a:ext>
+            </a:extLst>
+          </a:blip>
+          <a:stretch>
+            <a:fillRect/>
+          </a:stretch>
+        </p:blipFill>
+        <p:spPr>
+          <a:xfrm>
+            <a:off x="1624115" y="0"/>
+            <a:ext cx="3859306" cy="6858000"/>
+          </a:xfrm>
+          <a:prstGeom prst="rect">
+            <a:avLst/>
+          </a:prstGeom>
+        </p:spPr>
+      </p:pic>
+    </p:spTree>
+  </p:cSld>
+  <p:clrMapOvr>
+    <a:masterClrMapping/>
+  </p:clrMapOvr>
+</p:sld>
+</file>
+
+<file path=ppt/slides/slide18.xml><?xml version="1.0" encoding="utf-8"?>
+<p:sld xmlns:a="http://schemas.openxmlformats.org/drawingml/2006/main" xmlns:r="http://schemas.openxmlformats.org/officeDocument/2006/relationships" xmlns:p="http://schemas.openxmlformats.org/presentationml/2006/main">
+  <p:cSld>
+    <p:spTree>
+      <p:nvGrpSpPr>
+        <p:cNvPr id="1" name="">
+          <a:extLst>
+            <a:ext uri="{FF2B5EF4-FFF2-40B4-BE49-F238E27FC236}">
+              <a16:creationId xmlns:a16="http://schemas.microsoft.com/office/drawing/2014/main" id="{96E19A5E-CFF8-22A8-D808-A10BA8591206}"/>
+            </a:ext>
+          </a:extLst>
+        </p:cNvPr>
+        <p:cNvGrpSpPr/>
+        <p:nvPr/>
+      </p:nvGrpSpPr>
+      <p:grpSpPr>
+        <a:xfrm>
+          <a:off x="0" y="0"/>
+          <a:ext cx="0" cy="0"/>
+          <a:chOff x="0" y="0"/>
+          <a:chExt cx="0" cy="0"/>
+        </a:xfrm>
+      </p:grpSpPr>
+      <p:sp>
+        <p:nvSpPr>
+          <p:cNvPr id="5" name="TextBox 4">
+            <a:extLst>
+              <a:ext uri="{FF2B5EF4-FFF2-40B4-BE49-F238E27FC236}">
+                <a16:creationId xmlns:a16="http://schemas.microsoft.com/office/drawing/2014/main" id="{5103F445-F6A8-963B-D680-B7F2649BEE13}"/>
+              </a:ext>
+            </a:extLst>
+          </p:cNvPr>
+          <p:cNvSpPr txBox="1"/>
+          <p:nvPr/>
+        </p:nvSpPr>
+        <p:spPr>
+          <a:xfrm>
+            <a:off x="1020880" y="2667837"/>
+            <a:ext cx="10391400" cy="1823776"/>
+          </a:xfrm>
+          <a:prstGeom prst="rect">
+            <a:avLst/>
+          </a:prstGeom>
+          <a:noFill/>
+          <a:ln w="0">
+            <a:noFill/>
+          </a:ln>
+        </p:spPr>
+        <p:txBody>
+          <a:bodyPr lIns="90000" tIns="45000" rIns="90000" bIns="45000" anchor="t">
+            <a:noAutofit/>
+          </a:bodyPr>
+          <a:lstStyle/>
+          <a:p>
+            <a:pPr algn="ctr"/>
+            <a:endParaRPr lang="en-US" sz="1600" b="0" strike="noStrike" spc="-1" dirty="0">
+              <a:solidFill>
+                <a:srgbClr val="000000"/>
+              </a:solidFill>
+              <a:latin typeface="Arial" panose="020B0604020202020204" pitchFamily="34" charset="0"/>
+              <a:cs typeface="Arial" panose="020B0604020202020204" pitchFamily="34" charset="0"/>
+            </a:endParaRPr>
+          </a:p>
+        </p:txBody>
+      </p:sp>
+      <p:pic>
+        <p:nvPicPr>
+          <p:cNvPr id="3" name="Picture 2">
+            <a:extLst>
+              <a:ext uri="{FF2B5EF4-FFF2-40B4-BE49-F238E27FC236}">
+                <a16:creationId xmlns:a16="http://schemas.microsoft.com/office/drawing/2014/main" id="{9B3A356F-144A-1598-63DB-83DE71C4A9EA}"/>
+              </a:ext>
+            </a:extLst>
+          </p:cNvPr>
+          <p:cNvPicPr>
+            <a:picLocks noChangeAspect="1"/>
+          </p:cNvPicPr>
+          <p:nvPr/>
+        </p:nvPicPr>
+        <p:blipFill>
+          <a:blip r:embed="rId2" cstate="print">
+            <a:extLst>
+              <a:ext uri="{28A0092B-C50C-407E-A947-70E740481C1C}">
+                <a14:useLocalDpi xmlns:a14="http://schemas.microsoft.com/office/drawing/2010/main" val="0"/>
+              </a:ext>
+            </a:extLst>
+          </a:blip>
+          <a:stretch>
+            <a:fillRect/>
+          </a:stretch>
+        </p:blipFill>
+        <p:spPr>
+          <a:xfrm>
+            <a:off x="3108331" y="0"/>
+            <a:ext cx="5533247" cy="6858000"/>
+          </a:xfrm>
+          <a:prstGeom prst="rect">
+            <a:avLst/>
+          </a:prstGeom>
+        </p:spPr>
+      </p:pic>
+    </p:spTree>
+    <p:extLst>
+      <p:ext uri="{BB962C8B-B14F-4D97-AF65-F5344CB8AC3E}">
+        <p14:creationId xmlns:p14="http://schemas.microsoft.com/office/powerpoint/2010/main" val="2165489603"/>
+      </p:ext>
+    </p:extLst>
+  </p:cSld>
+  <p:clrMapOvr>
+    <a:masterClrMapping/>
+  </p:clrMapOvr>
+</p:sld>
+</file>
+
+<file path=ppt/slides/slide19.xml><?xml version="1.0" encoding="utf-8"?>
+<p:sld xmlns:a="http://schemas.openxmlformats.org/drawingml/2006/main" xmlns:r="http://schemas.openxmlformats.org/officeDocument/2006/relationships" xmlns:p="http://schemas.openxmlformats.org/presentationml/2006/main">
+  <p:cSld>
+    <p:spTree>
+      <p:nvGrpSpPr>
+        <p:cNvPr id="1" name="">
+          <a:extLst>
+            <a:ext uri="{FF2B5EF4-FFF2-40B4-BE49-F238E27FC236}">
+              <a16:creationId xmlns:a16="http://schemas.microsoft.com/office/drawing/2014/main" id="{FF5B4CAE-77E5-0C4A-8E38-42B7B0BF7166}"/>
+            </a:ext>
+          </a:extLst>
+        </p:cNvPr>
+        <p:cNvGrpSpPr/>
+        <p:nvPr/>
+      </p:nvGrpSpPr>
+      <p:grpSpPr>
+        <a:xfrm>
+          <a:off x="0" y="0"/>
+          <a:ext cx="0" cy="0"/>
+          <a:chOff x="0" y="0"/>
+          <a:chExt cx="0" cy="0"/>
+        </a:xfrm>
+      </p:grpSpPr>
+      <p:sp>
+        <p:nvSpPr>
+          <p:cNvPr id="5" name="TextBox 4">
+            <a:extLst>
+              <a:ext uri="{FF2B5EF4-FFF2-40B4-BE49-F238E27FC236}">
+                <a16:creationId xmlns:a16="http://schemas.microsoft.com/office/drawing/2014/main" id="{4DF758E7-CB95-21DD-D99C-5F5DC77FBEDF}"/>
+              </a:ext>
+            </a:extLst>
+          </p:cNvPr>
+          <p:cNvSpPr txBox="1"/>
+          <p:nvPr/>
+        </p:nvSpPr>
+        <p:spPr>
+          <a:xfrm>
+            <a:off x="900300" y="2527161"/>
+            <a:ext cx="10391400" cy="1823776"/>
+          </a:xfrm>
+          <a:prstGeom prst="rect">
+            <a:avLst/>
+          </a:prstGeom>
+          <a:noFill/>
+          <a:ln w="0">
+            <a:noFill/>
+          </a:ln>
+        </p:spPr>
+        <p:txBody>
+          <a:bodyPr lIns="90000" tIns="45000" rIns="90000" bIns="45000" anchor="t">
+            <a:noAutofit/>
+          </a:bodyPr>
+          <a:lstStyle/>
+          <a:p>
+            <a:pPr algn="ctr"/>
             <a:r>
               <a:rPr lang="en-US" sz="3600" b="1" strike="noStrike" spc="-1" dirty="0">
                 <a:solidFill>
@@ -18445,6 +18713,11 @@
         </p:txBody>
       </p:sp>
     </p:spTree>
+    <p:extLst>
+      <p:ext uri="{BB962C8B-B14F-4D97-AF65-F5344CB8AC3E}">
+        <p14:creationId xmlns:p14="http://schemas.microsoft.com/office/powerpoint/2010/main" val="522658771"/>
+      </p:ext>
+    </p:extLst>
   </p:cSld>
   <p:clrMapOvr>
     <a:masterClrMapping/>

</xml_diff>